<commit_message>
Swap CAD plan crops for the rendered masterplan
The rendered site plan replaces the working-drawing screenshots on the
context, landscaping and transport slides — no watermarks, no dimension
tags, and it reads at projector distance. The dimensioned CAD plan stays on
the genplan slide, where the 6.00/3.00/17.49/6.00 m setbacks are the point.

The render also settles what the CAD crop could not: a barriered ramp runs
under the main volume (underground parking) and a row of surface guest bays
sits along the western frontage, with access nodes at both the north-east
and south-west corners. The transport slide now states this instead of
hedging; the space count stays a blank for the client.

Drops the three superseded crops.

Co-Authored-By: Claude Opus 5 <noreply@anthropic.com>
Claude-Session: https://claude.ai/code/session_01Wn326a6Y6rDm3i5rqK96ac
</commit_message>
<xml_diff>
--- a/presentations/aurora-hotel/MOST_Bukhtarminskaya_akimat.pptx
+++ b/presentations/aurora-hotel/MOST_Bukhtarminskaya_akimat.pptx
@@ -962,8 +962,8 @@
           <a:p>
             <a:r>
               <a:rPr lang="en-US" dirty="0"/>
-              <a:t>ОСТОРОЖНО: на генплане парковочные места не размечены — видна только рампа въезда с запада. Не утверждать наличие подземного паркинга, пока это не подтверждено заказчиком.
-Число машино-мест вписать до показа — это первый вопрос акимата.</a:t>
+              <a:t>На визуализированном генплане читаются: рампа под корпусом со шлагбаумом (подземный паркинг) и ряд наземных гостевых мест вдоль западной кромки.
+Вместимость подземного паркинга по чертежу не считается — подтвердить у заказчика и вписать в плашку до показа. Это первый вопрос акимата.</a:t>
             </a:r>
             <a:endParaRPr lang="en-US" dirty="0"/>
           </a:p>
@@ -5519,7 +5519,7 @@
       </p:sp>
       <p:pic>
         <p:nvPicPr>
-          <p:cNvPr id="12" name="Image 0" descr="/tmp/claude-0/-home-user-most/9fc1ec31-3c64-5a82-aadb-ddb23fff6e53/scratchpad/assets/green.jpg">    </p:cNvPr>
+          <p:cNvPr id="12" name="Image 0" descr="/tmp/claude-0/-home-user-most/9fc1ec31-3c64-5a82-aadb-ddb23fff6e53/scratchpad/assets/plan_green.jpg">    </p:cNvPr>
           <p:cNvPicPr>
             <a:picLocks noChangeAspect="1"/>
           </p:cNvPicPr>
@@ -5574,7 +5574,7 @@
                 <a:ea typeface="Arial" pitchFamily="34" charset="-122"/>
                 <a:cs typeface="Arial" pitchFamily="34" charset="-120"/>
               </a:rPr>
-              <a:t>Фрагмент генплана: полоса озеленения между проездом и границей участка.</a:t>
+              <a:t>Зелёная полоса между кольцевым проездом и границей участка.</a:t>
             </a:r>
             <a:endParaRPr lang="en-US" sz="800" dirty="0"/>
           </a:p>
@@ -5890,7 +5890,7 @@
                 <a:ea typeface="Arial" pitchFamily="34" charset="-122"/>
                 <a:cs typeface="Arial" pitchFamily="34" charset="-120"/>
               </a:rPr>
-              <a:t>Единый узел въезда в западной части участка, со стороны внутриквартального проезда, а не напрямую с ул. Бухтарминской — уличный поток не разрывается.</a:t>
+              <a:t>Два узла въезда: северо-восточный со стороны ул. Бухтарминской и юго-западный со стороны внутриквартального проезда. Оба вынесены от перекрёстка.</a:t>
             </a:r>
             <a:endParaRPr lang="en-US" sz="1050" dirty="0"/>
           </a:p>
@@ -5933,7 +5933,7 @@
                 <a:ea typeface="Arial" pitchFamily="34" charset="-122"/>
                 <a:cs typeface="Arial" pitchFamily="34" charset="-120"/>
               </a:rPr>
-              <a:t>Кольцевой проезд вокруг застройки: подъезд ко всем входам, разгрузка и проезд пожарной техники.</a:t>
+              <a:t>Рампа в подземный паркинг — в юго-западной части, уходит под основной корпус; на въезде шлагбаум.</a:t>
             </a:r>
             <a:endParaRPr lang="en-US" sz="1050" dirty="0"/>
           </a:p>
@@ -5976,7 +5976,50 @@
                 <a:ea typeface="Arial" pitchFamily="34" charset="-122"/>
                 <a:cs typeface="Arial" pitchFamily="34" charset="-120"/>
               </a:rPr>
-              <a:t>Круговой подъезд к главному входу отделён от хозяйственного двора.</a:t>
+              <a:t>Наземные гостевые места вынесены на западную кромку, вдоль улицы — гостевой транспорт не заезжает во двор.</a:t>
+            </a:r>
+            <a:endParaRPr lang="en-US" sz="1050" dirty="0"/>
+          </a:p>
+          <a:p>
+            <a:pPr indent="0" marL="0">
+              <a:lnSpc>
+                <a:spcPts val="1500"/>
+              </a:lnSpc>
+              <a:spcAft>
+                <a:spcPts val="900"/>
+              </a:spcAft>
+              <a:buNone/>
+            </a:pPr>
+            <a:r>
+              <a:rPr lang="en-US" sz="1050" dirty="0">
+                <a:solidFill>
+                  <a:srgbClr val="FF4D23"/>
+                </a:solidFill>
+                <a:latin typeface="Arial" pitchFamily="34" charset="0"/>
+                <a:ea typeface="Arial" pitchFamily="34" charset="-122"/>
+                <a:cs typeface="Arial" pitchFamily="34" charset="-120"/>
+              </a:rPr>
+              <a:t>– </a:t>
+            </a:r>
+            <a:pPr indent="0" marL="0">
+              <a:lnSpc>
+                <a:spcPts val="1500"/>
+              </a:lnSpc>
+              <a:spcAft>
+                <a:spcPts val="900"/>
+              </a:spcAft>
+              <a:buNone/>
+            </a:pPr>
+            <a:r>
+              <a:rPr lang="en-US" sz="1050" dirty="0">
+                <a:solidFill>
+                  <a:srgbClr val="333333"/>
+                </a:solidFill>
+                <a:latin typeface="Arial" pitchFamily="34" charset="0"/>
+                <a:ea typeface="Arial" pitchFamily="34" charset="-122"/>
+                <a:cs typeface="Arial" pitchFamily="34" charset="-120"/>
+              </a:rPr>
+              <a:t>Кольцевой проезд вокруг застройки: подъезд ко всем входам, разгрузка и проезд пожарной техники.</a:t>
             </a:r>
             <a:endParaRPr lang="en-US" sz="1050" dirty="0"/>
           </a:p>
@@ -6082,7 +6125,7 @@
                 <a:ea typeface="Arial" pitchFamily="34" charset="-122"/>
                 <a:cs typeface="Arial" pitchFamily="34" charset="-120"/>
               </a:rPr>
-              <a:t>Количество и тип парковки определяются расчётом по нормативу к утверждённой ёмкости номерного фонда на стадии эскизного проекта.</a:t>
+              <a:t>Подземный паркинг под основным корпусом и наземные гостевые места вдоль западной границы. Итоговое количество определяется расчётом по нормативу к утверждённой ёмкости номерного фонда.</a:t>
             </a:r>
             <a:endParaRPr lang="en-US" sz="1000" dirty="0"/>
           </a:p>
@@ -6156,7 +6199,7 @@
       </p:sp>
       <p:pic>
         <p:nvPicPr>
-          <p:cNvPr id="12" name="Image 0" descr="/tmp/claude-0/-home-user-most/9fc1ec31-3c64-5a82-aadb-ddb23fff6e53/scratchpad/assets/entrance.jpg">    </p:cNvPr>
+          <p:cNvPr id="12" name="Image 0" descr="/tmp/claude-0/-home-user-most/9fc1ec31-3c64-5a82-aadb-ddb23fff6e53/scratchpad/assets/plan_transport.jpg">    </p:cNvPr>
           <p:cNvPicPr>
             <a:picLocks noChangeAspect="1"/>
           </p:cNvPicPr>
@@ -6211,7 +6254,7 @@
                 <a:ea typeface="Arial" pitchFamily="34" charset="-122"/>
                 <a:cs typeface="Arial" pitchFamily="34" charset="-120"/>
               </a:rPr>
-              <a:t>Фрагмент генплана: узел въезда в западной части участка.</a:t>
+              <a:t>Юго-западный узел: рампа в подземный паркинг под корпусом и ряд наземных гостевых мест вдоль улицы.</a:t>
             </a:r>
             <a:endParaRPr lang="en-US" sz="800" dirty="0"/>
           </a:p>
@@ -9320,7 +9363,7 @@
       </p:sp>
       <p:pic>
         <p:nvPicPr>
-          <p:cNvPr id="5" name="Image 0" descr="/tmp/claude-0/-home-user-most/9fc1ec31-3c64-5a82-aadb-ddb23fff6e53/scratchpad/assets/genplan_context.jpg">    </p:cNvPr>
+          <p:cNvPr id="5" name="Image 0" descr="/tmp/claude-0/-home-user-most/9fc1ec31-3c64-5a82-aadb-ddb23fff6e53/scratchpad/assets/plan_render.jpg">    </p:cNvPr>
           <p:cNvPicPr>
             <a:picLocks noChangeAspect="1"/>
           </p:cNvPicPr>
@@ -9334,8 +9377,8 @@
         </p:blipFill>
         <p:spPr>
           <a:xfrm>
-            <a:off x="502920" y="868680"/>
-            <a:ext cx="6053328" cy="5669280"/>
+            <a:off x="502920" y="960120"/>
+            <a:ext cx="6053328" cy="4544568"/>
           </a:xfrm>
           <a:prstGeom prst="rect">
             <a:avLst/>
@@ -9345,6 +9388,45 @@
       <p:sp>
         <p:nvSpPr>
           <p:cNvPr id="6" name="Text 3"/>
+          <p:cNvSpPr txBox="1"/>
+          <p:nvPr/>
+        </p:nvSpPr>
+        <p:spPr>
+          <a:xfrm>
+            <a:off x="502920" y="5596128"/>
+            <a:ext cx="6053328" cy="219456"/>
+          </a:xfrm>
+          <a:prstGeom prst="rect">
+            <a:avLst/>
+          </a:prstGeom>
+          <a:noFill/>
+          <a:ln/>
+        </p:spPr>
+        <p:txBody>
+          <a:bodyPr wrap="square" lIns="0" tIns="0" rIns="0" bIns="0" rtlCol="0" anchor="ctr"/>
+          <a:lstStyle/>
+          <a:p>
+            <a:pPr indent="0" marL="0">
+              <a:buNone/>
+            </a:pPr>
+            <a:r>
+              <a:rPr lang="en-US" sz="800" dirty="0">
+                <a:solidFill>
+                  <a:srgbClr val="8A8A8A"/>
+                </a:solidFill>
+                <a:latin typeface="Arial" pitchFamily="34" charset="0"/>
+                <a:ea typeface="Arial" pitchFamily="34" charset="-122"/>
+                <a:cs typeface="Arial" pitchFamily="34" charset="-120"/>
+              </a:rPr>
+              <a:t>Генеральный план в контексте квартала. Синим — граница участка, красным — границы смежных землепользований.</a:t>
+            </a:r>
+            <a:endParaRPr lang="en-US" sz="800" dirty="0"/>
+          </a:p>
+        </p:txBody>
+      </p:sp>
+      <p:sp>
+        <p:nvSpPr>
+          <p:cNvPr id="7" name="Text 4"/>
           <p:cNvSpPr txBox="1"/>
           <p:nvPr/>
         </p:nvSpPr>
@@ -9386,7 +9468,7 @@
       </p:sp>
       <p:sp>
         <p:nvSpPr>
-          <p:cNvPr id="7" name="Shape 4"/>
+          <p:cNvPr id="8" name="Shape 5"/>
           <p:cNvSpPr/>
           <p:nvPr/>
         </p:nvSpPr>
@@ -9411,7 +9493,7 @@
       </p:sp>
       <p:sp>
         <p:nvSpPr>
-          <p:cNvPr id="8" name="Text 5"/>
+          <p:cNvPr id="9" name="Text 6"/>
           <p:cNvSpPr txBox="1"/>
           <p:nvPr/>
         </p:nvSpPr>
@@ -9605,7 +9687,7 @@
       </p:sp>
       <p:sp>
         <p:nvSpPr>
-          <p:cNvPr id="9" name="Shape 6"/>
+          <p:cNvPr id="10" name="Shape 7"/>
           <p:cNvSpPr/>
           <p:nvPr/>
         </p:nvSpPr>
@@ -9630,7 +9712,7 @@
       </p:sp>
       <p:sp>
         <p:nvSpPr>
-          <p:cNvPr id="10" name="Text 7"/>
+          <p:cNvPr id="11" name="Text 8"/>
           <p:cNvSpPr txBox="1"/>
           <p:nvPr/>
         </p:nvSpPr>
@@ -9683,7 +9765,7 @@
       </p:sp>
       <p:sp>
         <p:nvSpPr>
-          <p:cNvPr id="11" name="Text 8"/>
+          <p:cNvPr id="12" name="Text 9"/>
           <p:cNvSpPr txBox="1"/>
           <p:nvPr/>
         </p:nvSpPr>
@@ -9725,7 +9807,7 @@
       </p:sp>
       <p:pic>
         <p:nvPicPr>
-          <p:cNvPr id="12" name="Image 1" descr="/tmp/claude-0/-home-user-most/9fc1ec31-3c64-5a82-aadb-ddb23fff6e53/scratchpad/assets/logo_most.png">    </p:cNvPr>
+          <p:cNvPr id="13" name="Image 1" descr="/tmp/claude-0/-home-user-most/9fc1ec31-3c64-5a82-aadb-ddb23fff6e53/scratchpad/assets/logo_most.png">    </p:cNvPr>
           <p:cNvPicPr>
             <a:picLocks noChangeAspect="1"/>
           </p:cNvPicPr>
@@ -9749,7 +9831,7 @@
       </p:pic>
       <p:sp>
         <p:nvSpPr>
-          <p:cNvPr id="13" name="Text 9"/>
+          <p:cNvPr id="14" name="Text 10"/>
           <p:cNvSpPr txBox="1"/>
           <p:nvPr/>
         </p:nvSpPr>

</xml_diff>